<commit_message>
add notebook for prompt variation in positive_cases
</commit_message>
<xml_diff>
--- a/slides/prediction_results_deck.pptx
+++ b/slides/prediction_results_deck.pptx
@@ -12,6 +12,7 @@
     <p:sldId id="259" r:id="rId6"/>
     <p:sldId id="260" r:id="rId7"/>
     <p:sldId id="261" r:id="rId8"/>
+    <p:sldId id="267" r:id="rId16"/>
     <p:sldId id="262" r:id="rId9"/>
     <p:sldId id="263" r:id="rId10"/>
     <p:sldId id="265" r:id="rId11"/>
@@ -3897,6 +3898,449 @@
 </p:sld>
 </file>
 
+<file path=ppt/slides/slide11.xml><?xml version="1.0" encoding="utf-8"?>
+<p:sld xmlns:a="http://schemas.openxmlformats.org/drawingml/2006/main" xmlns:p="http://schemas.openxmlformats.org/presentationml/2006/main" xmlns:r="http://schemas.openxmlformats.org/officeDocument/2006/relationships">
+  <p:cSld>
+    <p:bg>
+      <p:bgPr>
+        <a:solidFill>
+          <a:srgbClr val="F7F5F2"/>
+        </a:solidFill>
+        <a:effectLst/>
+      </p:bgPr>
+    </p:bg>
+    <p:spTree>
+      <p:nvGrpSpPr>
+        <p:cNvPr id="1" name=""/>
+        <p:cNvGrpSpPr/>
+        <p:nvPr/>
+      </p:nvGrpSpPr>
+      <p:grpSpPr/>
+      <p:sp>
+        <p:nvSpPr>
+          <p:cNvPr id="2" name="TextBox 1"/>
+          <p:cNvSpPr txBox="1"/>
+          <p:nvPr/>
+        </p:nvSpPr>
+        <p:spPr>
+          <a:xfrm>
+            <a:off x="502920" y="292608"/>
+            <a:ext cx="10881360" cy="594360"/>
+          </a:xfrm>
+          <a:prstGeom prst="rect">
+            <a:avLst/>
+          </a:prstGeom>
+          <a:noFill/>
+        </p:spPr>
+        <p:txBody>
+          <a:bodyPr wrap="none">
+            <a:spAutoFit/>
+          </a:bodyPr>
+          <a:lstStyle/>
+          <a:p>
+            <a:r>
+              <a:rPr sz="2400" b="1">
+                <a:solidFill>
+                  <a:srgbClr val="16324F"/>
+                </a:solidFill>
+                <a:latin typeface="Aptos Display"/>
+              </a:rPr>
+              <a:t>Do The LLM Shifts Match What Matters In The Data?</a:t>
+            </a:r>
+          </a:p>
+        </p:txBody>
+      </p:sp>
+      <p:sp>
+        <p:nvSpPr>
+          <p:cNvPr id="3" name="Rectangle 2"/>
+          <p:cNvSpPr/>
+          <p:nvPr/>
+        </p:nvSpPr>
+        <p:spPr>
+          <a:xfrm>
+            <a:off x="502920" y="896112"/>
+            <a:ext cx="11018520" cy="54864"/>
+          </a:xfrm>
+          <a:prstGeom prst="rect">
+            <a:avLst/>
+          </a:prstGeom>
+          <a:solidFill>
+            <a:srgbClr val="2A9D8F"/>
+          </a:solidFill>
+          <a:ln>
+            <a:noFill/>
+          </a:ln>
+        </p:spPr>
+        <p:style>
+          <a:lnRef idx="1">
+            <a:schemeClr val="accent1"/>
+          </a:lnRef>
+          <a:fillRef idx="3">
+            <a:schemeClr val="accent1"/>
+          </a:fillRef>
+          <a:effectRef idx="2">
+            <a:schemeClr val="accent1"/>
+          </a:effectRef>
+          <a:fontRef idx="minor">
+            <a:schemeClr val="lt1"/>
+          </a:fontRef>
+        </p:style>
+        <p:txBody>
+          <a:bodyPr rtlCol="0" anchor="ctr"/>
+          <a:lstStyle/>
+          <a:p>
+            <a:pPr algn="ctr"/>
+          </a:p>
+        </p:txBody>
+      </p:sp>
+      <p:sp>
+        <p:nvSpPr>
+          <p:cNvPr id="4" name="TextBox 3"/>
+          <p:cNvSpPr txBox="1"/>
+          <p:nvPr/>
+        </p:nvSpPr>
+        <p:spPr>
+          <a:xfrm>
+            <a:off x="548640" y="960120"/>
+            <a:ext cx="10789920" cy="274320"/>
+          </a:xfrm>
+          <a:prstGeom prst="rect">
+            <a:avLst/>
+          </a:prstGeom>
+          <a:noFill/>
+        </p:spPr>
+        <p:txBody>
+          <a:bodyPr wrap="none">
+            <a:spAutoFit/>
+          </a:bodyPr>
+          <a:lstStyle/>
+          <a:p>
+            <a:r>
+              <a:rPr sz="1050">
+                <a:solidFill>
+                  <a:srgbClr val="5A6672"/>
+                </a:solidFill>
+                <a:latin typeface="Aptos"/>
+              </a:rPr>
+              <a:t>Comparison against the manuscript's E-net feature-importance and SHAP analysis; this is a feature-level, not interaction-level, audit.</a:t>
+            </a:r>
+          </a:p>
+        </p:txBody>
+      </p:sp>
+      <p:sp>
+        <p:nvSpPr>
+          <p:cNvPr id="5" name="Rounded Rectangle 4"/>
+          <p:cNvSpPr/>
+          <p:nvPr/>
+        </p:nvSpPr>
+        <p:spPr>
+          <a:xfrm>
+            <a:off x="502920" y="1115568"/>
+            <a:ext cx="7680960" cy="4892040"/>
+          </a:xfrm>
+          <a:prstGeom prst="roundRect">
+            <a:avLst/>
+          </a:prstGeom>
+          <a:solidFill>
+            <a:srgbClr val="FFFFFF"/>
+          </a:solidFill>
+          <a:ln>
+            <a:solidFill>
+              <a:srgbClr val="DEE2E6"/>
+            </a:solidFill>
+          </a:ln>
+        </p:spPr>
+        <p:style>
+          <a:lnRef idx="1">
+            <a:schemeClr val="accent1"/>
+          </a:lnRef>
+          <a:fillRef idx="3">
+            <a:schemeClr val="accent1"/>
+          </a:fillRef>
+          <a:effectRef idx="2">
+            <a:schemeClr val="accent1"/>
+          </a:effectRef>
+          <a:fontRef idx="minor">
+            <a:schemeClr val="lt1"/>
+          </a:fontRef>
+        </p:style>
+        <p:txBody>
+          <a:bodyPr rtlCol="0" anchor="ctr"/>
+          <a:lstStyle/>
+          <a:p>
+            <a:pPr algn="ctr"/>
+          </a:p>
+        </p:txBody>
+      </p:sp>
+      <p:pic>
+        <p:nvPicPr>
+          <p:cNvPr id="6" name="Picture 5" descr="llm_shift_vs_enet_importance.png"/>
+          <p:cNvPicPr>
+            <a:picLocks noChangeAspect="1"/>
+          </p:cNvPicPr>
+          <p:nvPr/>
+        </p:nvPicPr>
+        <p:blipFill>
+          <a:blip r:embed="rId2"/>
+          <a:stretch>
+            <a:fillRect/>
+          </a:stretch>
+        </p:blipFill>
+        <p:spPr>
+          <a:xfrm>
+            <a:off x="640080" y="1234440"/>
+            <a:ext cx="7406640" cy="3131566"/>
+          </a:xfrm>
+          <a:prstGeom prst="rect">
+            <a:avLst/>
+          </a:prstGeom>
+        </p:spPr>
+      </p:pic>
+      <p:sp>
+        <p:nvSpPr>
+          <p:cNvPr id="7" name="Rounded Rectangle 6"/>
+          <p:cNvSpPr/>
+          <p:nvPr/>
+        </p:nvSpPr>
+        <p:spPr>
+          <a:xfrm>
+            <a:off x="8275320" y="1261872"/>
+            <a:ext cx="3200400" cy="4297680"/>
+          </a:xfrm>
+          <a:prstGeom prst="roundRect">
+            <a:avLst/>
+          </a:prstGeom>
+          <a:solidFill>
+            <a:srgbClr val="FDFAF5"/>
+          </a:solidFill>
+          <a:ln>
+            <a:solidFill>
+              <a:srgbClr val="EBDDD0"/>
+            </a:solidFill>
+          </a:ln>
+        </p:spPr>
+        <p:style>
+          <a:lnRef idx="1">
+            <a:schemeClr val="accent1"/>
+          </a:lnRef>
+          <a:fillRef idx="3">
+            <a:schemeClr val="accent1"/>
+          </a:fillRef>
+          <a:effectRef idx="2">
+            <a:schemeClr val="accent1"/>
+          </a:effectRef>
+          <a:fontRef idx="minor">
+            <a:schemeClr val="lt1"/>
+          </a:fontRef>
+        </p:style>
+        <p:txBody>
+          <a:bodyPr rtlCol="0" anchor="ctr"/>
+          <a:lstStyle/>
+          <a:p>
+            <a:pPr algn="ctr"/>
+          </a:p>
+        </p:txBody>
+      </p:sp>
+      <p:sp>
+        <p:nvSpPr>
+          <p:cNvPr id="8" name="Rectangle 7"/>
+          <p:cNvSpPr/>
+          <p:nvPr/>
+        </p:nvSpPr>
+        <p:spPr>
+          <a:xfrm>
+            <a:off x="8275320" y="1261872"/>
+            <a:ext cx="109728" cy="4297680"/>
+          </a:xfrm>
+          <a:prstGeom prst="rect">
+            <a:avLst/>
+          </a:prstGeom>
+          <a:solidFill>
+            <a:srgbClr val="2A9D8F"/>
+          </a:solidFill>
+          <a:ln>
+            <a:noFill/>
+          </a:ln>
+        </p:spPr>
+        <p:style>
+          <a:lnRef idx="1">
+            <a:schemeClr val="accent1"/>
+          </a:lnRef>
+          <a:fillRef idx="3">
+            <a:schemeClr val="accent1"/>
+          </a:fillRef>
+          <a:effectRef idx="2">
+            <a:schemeClr val="accent1"/>
+          </a:effectRef>
+          <a:fontRef idx="minor">
+            <a:schemeClr val="lt1"/>
+          </a:fontRef>
+        </p:style>
+        <p:txBody>
+          <a:bodyPr rtlCol="0" anchor="ctr"/>
+          <a:lstStyle/>
+          <a:p>
+            <a:pPr algn="ctr"/>
+          </a:p>
+        </p:txBody>
+      </p:sp>
+      <p:sp>
+        <p:nvSpPr>
+          <p:cNvPr id="9" name="TextBox 8"/>
+          <p:cNvSpPr txBox="1"/>
+          <p:nvPr/>
+        </p:nvSpPr>
+        <p:spPr>
+          <a:xfrm>
+            <a:off x="8476488" y="1399031"/>
+            <a:ext cx="2907792" cy="4114800"/>
+          </a:xfrm>
+          <a:prstGeom prst="rect">
+            <a:avLst/>
+          </a:prstGeom>
+          <a:noFill/>
+        </p:spPr>
+        <p:txBody>
+          <a:bodyPr wrap="square">
+            <a:spAutoFit/>
+          </a:bodyPr>
+          <a:lstStyle/>
+          <a:p>
+            <a:pPr>
+              <a:spcAft>
+                <a:spcPts val="400"/>
+              </a:spcAft>
+              <a:defRPr sz="1400">
+                <a:solidFill>
+                  <a:srgbClr val="1F2933"/>
+                </a:solidFill>
+                <a:latin typeface="Aptos"/>
+              </a:defRPr>
+            </a:pPr>
+            <a:r>
+              <a:t>Yes for communication: it is the highest-importance E-net feature and also the largest aligned LLM shift.</a:t>
+            </a:r>
+          </a:p>
+          <a:p>
+            <a:pPr>
+              <a:spcAft>
+                <a:spcPts val="400"/>
+              </a:spcAft>
+              <a:defRPr sz="1400">
+                <a:solidFill>
+                  <a:srgbClr val="1F2933"/>
+                </a:solidFill>
+                <a:latin typeface="Aptos"/>
+              </a:defRPr>
+            </a:pPr>
+            <a:r>
+              <a:t>But several features look miscalibrated: peer incentive cost and group size are overindexed, while game length and contribution framing look underweighted.</a:t>
+            </a:r>
+          </a:p>
+          <a:p>
+            <a:pPr>
+              <a:spcAft>
+                <a:spcPts val="400"/>
+              </a:spcAft>
+              <a:defRPr sz="1400">
+                <a:solidFill>
+                  <a:srgbClr val="1F2933"/>
+                </a:solidFill>
+                <a:latin typeface="Aptos"/>
+              </a:defRPr>
+            </a:pPr>
+            <a:r>
+              <a:t>This first pass compares feature-level main effects; checking interaction mismatch would require a second pass against manuscript Figure 5.</a:t>
+            </a:r>
+          </a:p>
+        </p:txBody>
+      </p:sp>
+      <p:sp>
+        <p:nvSpPr>
+          <p:cNvPr id="10" name="Rounded Rectangle 9"/>
+          <p:cNvSpPr/>
+          <p:nvPr/>
+        </p:nvSpPr>
+        <p:spPr>
+          <a:xfrm>
+            <a:off x="594360" y="6144768"/>
+            <a:ext cx="10972800" cy="384048"/>
+          </a:xfrm>
+          <a:prstGeom prst="roundRect">
+            <a:avLst/>
+          </a:prstGeom>
+          <a:solidFill>
+            <a:srgbClr val="16324F"/>
+          </a:solidFill>
+          <a:ln>
+            <a:noFill/>
+          </a:ln>
+        </p:spPr>
+        <p:style>
+          <a:lnRef idx="1">
+            <a:schemeClr val="accent1"/>
+          </a:lnRef>
+          <a:fillRef idx="3">
+            <a:schemeClr val="accent1"/>
+          </a:fillRef>
+          <a:effectRef idx="2">
+            <a:schemeClr val="accent1"/>
+          </a:effectRef>
+          <a:fontRef idx="minor">
+            <a:schemeClr val="lt1"/>
+          </a:fontRef>
+        </p:style>
+        <p:txBody>
+          <a:bodyPr rtlCol="0" anchor="ctr"/>
+          <a:lstStyle/>
+          <a:p>
+            <a:pPr algn="ctr"/>
+          </a:p>
+        </p:txBody>
+      </p:sp>
+      <p:sp>
+        <p:nvSpPr>
+          <p:cNvPr id="11" name="TextBox 10"/>
+          <p:cNvSpPr txBox="1"/>
+          <p:nvPr/>
+        </p:nvSpPr>
+        <p:spPr>
+          <a:xfrm>
+            <a:off x="777240" y="6208776"/>
+            <a:ext cx="10698480" cy="219456"/>
+          </a:xfrm>
+          <a:prstGeom prst="rect">
+            <a:avLst/>
+          </a:prstGeom>
+          <a:noFill/>
+        </p:spPr>
+        <p:txBody>
+          <a:bodyPr wrap="none">
+            <a:spAutoFit/>
+          </a:bodyPr>
+          <a:lstStyle/>
+          <a:p>
+            <a:pPr algn="ctr"/>
+            <a:r>
+              <a:rPr sz="1100" b="1">
+                <a:solidFill>
+                  <a:srgbClr val="FFFFFF"/>
+                </a:solidFill>
+                <a:latin typeface="Aptos"/>
+              </a:rPr>
+              <a:t>The augmented LLM is not random, but some of its biggest shifts still look misaligned with the data-driven model.</a:t>
+            </a:r>
+          </a:p>
+        </p:txBody>
+      </p:sp>
+    </p:spTree>
+  </p:cSld>
+  <p:clrMapOvr>
+    <a:masterClrMapping/>
+  </p:clrMapOvr>
+</p:sld>
+</file>
+
 <file path=ppt/slides/slide2.xml><?xml version="1.0" encoding="utf-8"?>
 <p:sld xmlns:a="http://schemas.openxmlformats.org/drawingml/2006/main" xmlns:r="http://schemas.openxmlformats.org/officeDocument/2006/relationships" xmlns:p="http://schemas.openxmlformats.org/presentationml/2006/main">
   <p:cSld>
@@ -5748,7 +6192,7 @@
                 </a:solidFill>
                 <a:latin typeface="Aptos Display"/>
               </a:rPr>
-              <a:t>Where Augmentation Helps</a:t>
+              <a:t>Where Augmentation Helps, With Writing-Level Granularity</a:t>
             </a:r>
           </a:p>
         </p:txBody>
@@ -5793,7 +6237,6 @@
           <a:lstStyle/>
           <a:p>
             <a:pPr algn="ctr"/>
-            <a:endParaRPr/>
           </a:p>
         </p:txBody>
       </p:sp>
@@ -5826,29 +6269,74 @@
                 </a:solidFill>
                 <a:latin typeface="Aptos"/>
               </a:rPr>
-              <a:t>Grouped by input family and elicitation mode across validation and learning waves.</a:t>
-            </a:r>
+              <a:t>Each cell is one exact positive-case writing family, not an average over multiple writing versions.</a:t>
+            </a:r>
+          </a:p>
+        </p:txBody>
+      </p:sp>
+      <p:sp>
+        <p:nvSpPr>
+          <p:cNvPr id="5" name="Rounded Rectangle 4"/>
+          <p:cNvSpPr/>
+          <p:nvPr/>
+        </p:nvSpPr>
+        <p:spPr>
+          <a:xfrm>
+            <a:off x="502920" y="1115568"/>
+            <a:ext cx="7680960" cy="4892040"/>
+          </a:xfrm>
+          <a:prstGeom prst="roundRect">
+            <a:avLst/>
+          </a:prstGeom>
+          <a:solidFill>
+            <a:srgbClr val="FFFFFF"/>
+          </a:solidFill>
+          <a:ln>
+            <a:solidFill>
+              <a:srgbClr val="DEE2E6"/>
+            </a:solidFill>
+          </a:ln>
+        </p:spPr>
+        <p:style>
+          <a:lnRef idx="1">
+            <a:schemeClr val="accent1"/>
+          </a:lnRef>
+          <a:fillRef idx="3">
+            <a:schemeClr val="accent1"/>
+          </a:fillRef>
+          <a:effectRef idx="2">
+            <a:schemeClr val="accent1"/>
+          </a:effectRef>
+          <a:fontRef idx="minor">
+            <a:schemeClr val="lt1"/>
+          </a:fontRef>
+        </p:style>
+        <p:txBody>
+          <a:bodyPr rtlCol="0" anchor="ctr"/>
+          <a:lstStyle/>
+          <a:p>
+            <a:pPr algn="ctr"/>
           </a:p>
         </p:txBody>
       </p:sp>
       <p:pic>
         <p:nvPicPr>
-          <p:cNvPr id="6" name="Picture 5" descr="crosswave_augmentation_performance_heatmap.png"/>
+          <p:cNvPr id="6" name="Picture 5" descr="granular_performance_delta_r2_heatmap.png"/>
           <p:cNvPicPr>
             <a:picLocks noChangeAspect="1"/>
           </p:cNvPicPr>
           <p:nvPr/>
         </p:nvPicPr>
         <p:blipFill>
-          <a:blip r:embed="rId2"/>
+          <a:blip r:embed="rId3"/>
           <a:stretch>
             <a:fillRect/>
           </a:stretch>
         </p:blipFill>
         <p:spPr>
           <a:xfrm>
-            <a:off x="621792" y="1207008"/>
-            <a:ext cx="7315200" cy="3358691"/>
+            <a:off x="640080" y="1234440"/>
+            <a:ext cx="7406640" cy="4365656"/>
           </a:xfrm>
           <a:prstGeom prst="rect">
             <a:avLst/>
@@ -5863,8 +6351,8 @@
         </p:nvSpPr>
         <p:spPr>
           <a:xfrm>
-            <a:off x="8275320" y="1234440"/>
-            <a:ext cx="3246120" cy="4480560"/>
+            <a:off x="8275320" y="1261872"/>
+            <a:ext cx="3200400" cy="4297680"/>
           </a:xfrm>
           <a:prstGeom prst="roundRect">
             <a:avLst/>
@@ -5897,7 +6385,6 @@
           <a:lstStyle/>
           <a:p>
             <a:pPr algn="ctr"/>
-            <a:endParaRPr/>
           </a:p>
         </p:txBody>
       </p:sp>
@@ -5909,14 +6396,14 @@
         </p:nvSpPr>
         <p:spPr>
           <a:xfrm>
-            <a:off x="8275320" y="1234440"/>
-            <a:ext cx="109728" cy="4480560"/>
+            <a:off x="8275320" y="1261872"/>
+            <a:ext cx="109728" cy="4297680"/>
           </a:xfrm>
           <a:prstGeom prst="rect">
             <a:avLst/>
           </a:prstGeom>
           <a:solidFill>
-            <a:srgbClr val="F4A261"/>
+            <a:srgbClr val="2A9D8F"/>
           </a:solidFill>
           <a:ln>
             <a:noFill/>
@@ -5941,7 +6428,6 @@
           <a:lstStyle/>
           <a:p>
             <a:pPr algn="ctr"/>
-            <a:endParaRPr/>
           </a:p>
         </p:txBody>
       </p:sp>
@@ -5953,8 +6439,8 @@
         </p:nvSpPr>
         <p:spPr>
           <a:xfrm>
-            <a:off x="8476488" y="1380744"/>
-            <a:ext cx="2971800" cy="4297680"/>
+            <a:off x="8476488" y="1399031"/>
+            <a:ext cx="2907792" cy="4114800"/>
           </a:xfrm>
           <a:prstGeom prst="rect">
             <a:avLst/>
@@ -5969,9 +6455,9 @@
           <a:p>
             <a:pPr>
               <a:spcAft>
-                <a:spcPts val="500"/>
+                <a:spcPts val="400"/>
               </a:spcAft>
-              <a:defRPr sz="1500">
+              <a:defRPr sz="1400">
                 <a:solidFill>
                   <a:srgbClr val="1F2933"/>
                 </a:solidFill>
@@ -5979,15 +6465,15 @@
               </a:defRPr>
             </a:pPr>
             <a:r>
-              <a:t>Validation: gains are limited and mostly concentrated in correlation rather than RMSE/R².</a:t>
+              <a:t>Validation winners are concentrated in a few exact families, especially both/contrastive, both/structured, and both/uncertainty under joint-like modes.</a:t>
             </a:r>
           </a:p>
           <a:p>
             <a:pPr>
               <a:spcAft>
-                <a:spcPts val="500"/>
+                <a:spcPts val="400"/>
               </a:spcAft>
-              <a:defRPr sz="1500">
+              <a:defRPr sz="1400">
                 <a:solidFill>
                   <a:srgbClr val="1F2933"/>
                 </a:solidFill>
@@ -5995,15 +6481,15 @@
               </a:defRPr>
             </a:pPr>
             <a:r>
-              <a:t>Learning: both + joint is the strongest GPT-4.1 region; paper_only can also help.</a:t>
+              <a:t>Learning is much cleaner: both and paper_only families become positive mainly under joint or joint_reasoning, while data_only stays weak.</a:t>
             </a:r>
           </a:p>
           <a:p>
             <a:pPr>
               <a:spcAft>
-                <a:spcPts val="500"/>
+                <a:spcPts val="400"/>
               </a:spcAft>
-              <a:defRPr sz="1500">
+              <a:defRPr sz="1400">
                 <a:solidFill>
                   <a:srgbClr val="1F2933"/>
                 </a:solidFill>
@@ -6011,7 +6497,7 @@
               </a:defRPr>
             </a:pPr>
             <a:r>
-              <a:t>Data_only is consistently weak across waves and metrics.</a:t>
+              <a:t>Granularity shows that 'augmentation helps' is too coarse; the exact writing family matters.</a:t>
             </a:r>
           </a:p>
         </p:txBody>
@@ -6056,7 +6542,6 @@
           <a:lstStyle/>
           <a:p>
             <a:pPr algn="ctr"/>
-            <a:endParaRPr/>
           </a:p>
         </p:txBody>
       </p:sp>
@@ -6090,7 +6575,7 @@
                 </a:solidFill>
                 <a:latin typeface="Aptos"/>
               </a:rPr>
-              <a:t>Augmentation helps only in selective regimes, not as a general recipe.</a:t>
+              <a:t>The writing family is part of the treatment: averaging across them hides real heterogeneity.</a:t>
             </a:r>
           </a:p>
         </p:txBody>
@@ -6157,7 +6642,7 @@
                 </a:solidFill>
                 <a:latin typeface="Aptos Display"/>
               </a:rPr>
-              <a:t>Augmentation Changes The Model's Priors</a:t>
+              <a:t>Communication Shift Is Real, But It Does Not Buy Performance By Itself</a:t>
             </a:r>
           </a:p>
         </p:txBody>
@@ -6202,7 +6687,6 @@
           <a:lstStyle/>
           <a:p>
             <a:pPr algn="ctr"/>
-            <a:endParaRPr/>
           </a:p>
         </p:txBody>
       </p:sp>
@@ -6235,29 +6719,74 @@
                 </a:solidFill>
                 <a:latin typeface="Aptos"/>
               </a:rPr>
-              <a:t>Cell values show how augmentation changes the predicted treatment-effect contrast associated with each binary CONFIG.</a:t>
-            </a:r>
+              <a:t>Here the feature shift is shown at exact writing-family granularity relative to the matched no-input baseline.</a:t>
+            </a:r>
+          </a:p>
+        </p:txBody>
+      </p:sp>
+      <p:sp>
+        <p:nvSpPr>
+          <p:cNvPr id="5" name="Rounded Rectangle 4"/>
+          <p:cNvSpPr/>
+          <p:nvPr/>
+        </p:nvSpPr>
+        <p:spPr>
+          <a:xfrm>
+            <a:off x="502920" y="1115568"/>
+            <a:ext cx="7680960" cy="4892040"/>
+          </a:xfrm>
+          <a:prstGeom prst="roundRect">
+            <a:avLst/>
+          </a:prstGeom>
+          <a:solidFill>
+            <a:srgbClr val="FFFFFF"/>
+          </a:solidFill>
+          <a:ln>
+            <a:solidFill>
+              <a:srgbClr val="DEE2E6"/>
+            </a:solidFill>
+          </a:ln>
+        </p:spPr>
+        <p:style>
+          <a:lnRef idx="1">
+            <a:schemeClr val="accent1"/>
+          </a:lnRef>
+          <a:fillRef idx="3">
+            <a:schemeClr val="accent1"/>
+          </a:fillRef>
+          <a:effectRef idx="2">
+            <a:schemeClr val="accent1"/>
+          </a:effectRef>
+          <a:fontRef idx="minor">
+            <a:schemeClr val="lt1"/>
+          </a:fontRef>
+        </p:style>
+        <p:txBody>
+          <a:bodyPr rtlCol="0" anchor="ctr"/>
+          <a:lstStyle/>
+          <a:p>
+            <a:pPr algn="ctr"/>
           </a:p>
         </p:txBody>
       </p:sp>
       <p:pic>
         <p:nvPicPr>
-          <p:cNvPr id="6" name="Picture 5" descr="crosswave_config_augmentation_binary_delta_heatmap.png"/>
+          <p:cNvPr id="6" name="Picture 5" descr="granular_chat_shift_heatmap.png"/>
           <p:cNvPicPr>
             <a:picLocks noChangeAspect="1"/>
           </p:cNvPicPr>
           <p:nvPr/>
         </p:nvPicPr>
         <p:blipFill>
-          <a:blip r:embed="rId2"/>
+          <a:blip r:embed="rId3"/>
           <a:stretch>
             <a:fillRect/>
           </a:stretch>
         </p:blipFill>
         <p:spPr>
           <a:xfrm>
-            <a:off x="621792" y="1207008"/>
-            <a:ext cx="7315200" cy="5021471"/>
+            <a:off x="640080" y="1234440"/>
+            <a:ext cx="7406640" cy="4365656"/>
           </a:xfrm>
           <a:prstGeom prst="rect">
             <a:avLst/>
@@ -6272,8 +6801,8 @@
         </p:nvSpPr>
         <p:spPr>
           <a:xfrm>
-            <a:off x="8275320" y="1234440"/>
-            <a:ext cx="3246120" cy="4480560"/>
+            <a:off x="8275320" y="1261872"/>
+            <a:ext cx="3200400" cy="4297680"/>
           </a:xfrm>
           <a:prstGeom prst="roundRect">
             <a:avLst/>
@@ -6306,7 +6835,6 @@
           <a:lstStyle/>
           <a:p>
             <a:pPr algn="ctr"/>
-            <a:endParaRPr/>
           </a:p>
         </p:txBody>
       </p:sp>
@@ -6318,14 +6846,14 @@
         </p:nvSpPr>
         <p:spPr>
           <a:xfrm>
-            <a:off x="8275320" y="1234440"/>
-            <a:ext cx="109728" cy="4480560"/>
+            <a:off x="8275320" y="1261872"/>
+            <a:ext cx="109728" cy="4297680"/>
           </a:xfrm>
           <a:prstGeom prst="rect">
             <a:avLst/>
           </a:prstGeom>
           <a:solidFill>
-            <a:srgbClr val="F4A261"/>
+            <a:srgbClr val="2A9D8F"/>
           </a:solidFill>
           <a:ln>
             <a:noFill/>
@@ -6350,7 +6878,6 @@
           <a:lstStyle/>
           <a:p>
             <a:pPr algn="ctr"/>
-            <a:endParaRPr/>
           </a:p>
         </p:txBody>
       </p:sp>
@@ -6362,8 +6889,8 @@
         </p:nvSpPr>
         <p:spPr>
           <a:xfrm>
-            <a:off x="8476488" y="1380744"/>
-            <a:ext cx="2971800" cy="4297680"/>
+            <a:off x="8476488" y="1399031"/>
+            <a:ext cx="2907792" cy="4114800"/>
           </a:xfrm>
           <a:prstGeom prst="rect">
             <a:avLst/>
@@ -6378,9 +6905,9 @@
           <a:p>
             <a:pPr>
               <a:spcAft>
-                <a:spcPts val="500"/>
+                <a:spcPts val="400"/>
               </a:spcAft>
-              <a:defRPr sz="1500">
+              <a:defRPr sz="1400">
                 <a:solidFill>
                   <a:srgbClr val="1F2933"/>
                 </a:solidFill>
@@ -6388,15 +6915,15 @@
               </a:defRPr>
             </a:pPr>
             <a:r>
-              <a:t>Changes are substantive, not cosmetic: augmentation shifts the model's response to chat, rewardExists, and showOtherSummaries.</a:t>
+              <a:t>On learning, most both and paper_only families push communication sharply upward; validation shifts are much smaller.</a:t>
             </a:r>
           </a:p>
           <a:p>
             <a:pPr>
               <a:spcAft>
-                <a:spcPts val="500"/>
+                <a:spcPts val="400"/>
               </a:spcAft>
-              <a:defRPr sz="1500">
+              <a:defRPr sz="1400">
                 <a:solidFill>
                   <a:srgbClr val="1F2933"/>
                 </a:solidFill>
@@ -6404,15 +6931,15 @@
               </a:defRPr>
             </a:pPr>
             <a:r>
-              <a:t>These shifts depend on both input family and elicitation mode.</a:t>
+              <a:t>Data_only is unstable and can even reverse direction, especially on learning.</a:t>
             </a:r>
           </a:p>
           <a:p>
             <a:pPr>
               <a:spcAft>
-                <a:spcPts val="500"/>
+                <a:spcPts val="400"/>
               </a:spcAft>
-              <a:defRPr sz="1500">
+              <a:defRPr sz="1400">
                 <a:solidFill>
                   <a:srgbClr val="1F2933"/>
                 </a:solidFill>
@@ -6420,7 +6947,85 @@
               </a:defRPr>
             </a:pPr>
             <a:r>
-              <a:t>Performance differences and belief changes move together; augmentation is changing what the model keys on.</a:t>
+              <a:t>This shift is not enough on its own: corr(chat shift, ΔR²) is -0.01 on validation and only 0.26 on learning.</a:t>
+            </a:r>
+          </a:p>
+        </p:txBody>
+      </p:sp>
+      <p:sp>
+        <p:nvSpPr>
+          <p:cNvPr id="10" name="Rounded Rectangle 9"/>
+          <p:cNvSpPr/>
+          <p:nvPr/>
+        </p:nvSpPr>
+        <p:spPr>
+          <a:xfrm>
+            <a:off x="594360" y="6144768"/>
+            <a:ext cx="10972800" cy="384048"/>
+          </a:xfrm>
+          <a:prstGeom prst="roundRect">
+            <a:avLst/>
+          </a:prstGeom>
+          <a:solidFill>
+            <a:srgbClr val="16324F"/>
+          </a:solidFill>
+          <a:ln>
+            <a:noFill/>
+          </a:ln>
+        </p:spPr>
+        <p:style>
+          <a:lnRef idx="1">
+            <a:schemeClr val="accent1"/>
+          </a:lnRef>
+          <a:fillRef idx="3">
+            <a:schemeClr val="accent1"/>
+          </a:fillRef>
+          <a:effectRef idx="2">
+            <a:schemeClr val="accent1"/>
+          </a:effectRef>
+          <a:fontRef idx="minor">
+            <a:schemeClr val="lt1"/>
+          </a:fontRef>
+        </p:style>
+        <p:txBody>
+          <a:bodyPr rtlCol="0" anchor="ctr"/>
+          <a:lstStyle/>
+          <a:p>
+            <a:pPr algn="ctr"/>
+          </a:p>
+        </p:txBody>
+      </p:sp>
+      <p:sp>
+        <p:nvSpPr>
+          <p:cNvPr id="11" name="TextBox 10"/>
+          <p:cNvSpPr txBox="1"/>
+          <p:nvPr/>
+        </p:nvSpPr>
+        <p:spPr>
+          <a:xfrm>
+            <a:off x="777240" y="6208776"/>
+            <a:ext cx="10698480" cy="219456"/>
+          </a:xfrm>
+          <a:prstGeom prst="rect">
+            <a:avLst/>
+          </a:prstGeom>
+          <a:noFill/>
+        </p:spPr>
+        <p:txBody>
+          <a:bodyPr wrap="none">
+            <a:spAutoFit/>
+          </a:bodyPr>
+          <a:lstStyle/>
+          <a:p>
+            <a:pPr algn="ctr"/>
+            <a:r>
+              <a:rPr sz="1100" b="1">
+                <a:solidFill>
+                  <a:srgbClr val="FFFFFF"/>
+                </a:solidFill>
+                <a:latin typeface="Aptos"/>
+              </a:rPr>
+              <a:t>A meaningful belief shift is not the same as a predictive gain.</a:t>
             </a:r>
           </a:p>
         </p:txBody>

</xml_diff>